<commit_message>
Informe y presentacion: profesora guia Ana Rosa Moya Beltran y nota de uso autorizado de IA
Co-Authored-By: Claude Sonnet 5.5 <noreply@anthropic.com>
</commit_message>
<xml_diff>
--- a/docs/informe_titulo2/ppt/Presentacion_Titulo_II_Sprints_1_a_4.pptx
+++ b/docs/informe_titulo2/ppt/Presentacion_Titulo_II_Sprints_1_a_4.pptx
@@ -121,31 +121,31 @@
   <p:extLst>
     <p:ext uri="{521415D9-36F7-43E2-AB2F-B90AF26B5E84}">
       <p14:sectionLst xmlns:p14="http://schemas.microsoft.com/office/powerpoint/2010/main">
-        <p14:section name="Introducción" id="{52ad9549-9053-8024-73bf-275784b4b471}">
+        <p14:section name="Introducción" id="{fdb90bf1-49f0-0b12-d4d7-6cec0976e6e6}">
           <p14:sldIdLst>
             <p14:sldId id="256"/>
             <p14:sldId id="257"/>
           </p14:sldIdLst>
         </p14:section>
-        <p14:section name="Plan" id="{1175b2fd-bb22-6736-674a-364f9dba5401}">
+        <p14:section name="Plan" id="{0dc277a2-2ab4-39f3-d28a-9d7b07bc010b}">
           <p14:sldIdLst>
             <p14:sldId id="258"/>
             <p14:sldId id="259"/>
           </p14:sldIdLst>
         </p14:section>
-        <p14:section name="Sprint 1 y 2" id="{28750bad-7df6-b826-52d3-69d68d3e2980}">
+        <p14:section name="Sprint 1 y 2" id="{0e5894b2-d358-9986-c8b9-49fd899bba43}">
           <p14:sldIdLst>
             <p14:sldId id="260"/>
             <p14:sldId id="261"/>
           </p14:sldIdLst>
         </p14:section>
-        <p14:section name="Sprint 3" id="{5f2f248f-3575-ea97-93b0-f1830dc147be}">
+        <p14:section name="Sprint 3" id="{2d9a5b3e-11c9-68c3-0330-bd837552cf96}">
           <p14:sldIdLst>
             <p14:sldId id="262"/>
             <p14:sldId id="263"/>
           </p14:sldIdLst>
         </p14:section>
-        <p14:section name="Sprint 4" id="{f1a77a6f-ec5e-d8f5-879d-8249d5ef1240}">
+        <p14:section name="Sprint 4" id="{88b64459-3ba2-bbf9-d32e-8caa0d39fc5f}">
           <p14:sldIdLst>
             <p14:sldId id="264"/>
             <p14:sldId id="265"/>
@@ -153,7 +153,7 @@
             <p14:sldId id="267"/>
           </p14:sldIdLst>
         </p14:section>
-        <p14:section name="Balance" id="{1e24e377-dab0-4c93-6bdf-0afd1ca7b317}">
+        <p14:section name="Balance" id="{bc9520ff-e7e5-e133-decd-66211ed3349d}">
           <p14:sldIdLst>
             <p14:sldId id="268"/>
             <p14:sldId id="269"/>
@@ -1227,7 +1227,7 @@
               <a:rPr lang="en-US" dirty="0"/>
               <a:t>PRESENTACIÓN GRUPAL. Cómo usar este PPT para estudiar: cada diapositiva tiene un guion en las notas con (1) qué decir, (2) datos clave y (3) preguntas probables. Duración sugerida: 15 a 20 minutos.
 Apertura (30 segundos): "Presentamos el avance del Título II hasta el cierre del Sprint 4. Vamos a mostrar qué se hizo, para qué se hizo y quién lo hizo, siguiendo el plan de hitos y sprints del Título I."
-Antecedentes: el proyecto es de tres integrantes: Mauricio Reynoso (redes y PPO), Benjamín Farias (datos y calibración) y Paolo Sepúlveda (arquitectura del entorno, validación y benchmarks). El profesor guía es Juan Pablo Argerstein.</a:t>
+Antecedentes: el proyecto es de tres integrantes: Mauricio Reynoso (redes y PPO), Benjamín Farias (datos y calibración) y Paolo Sepúlveda (arquitectura del entorno, validación y benchmarks). La profesora guía es Ana Rosa Moya Beltrán.</a:t>
             </a:r>
             <a:endParaRPr lang="en-US" dirty="0"/>
           </a:p>
@@ -3320,7 +3320,7 @@
                 <a:ea typeface="Calibri" pitchFamily="34" charset="-122"/>
                 <a:cs typeface="Calibri" pitchFamily="34" charset="-120"/>
               </a:rPr>
-              <a:t>Profesor guía: Juan Pablo Argerstein · UTEM, 22 de octubre de 2026</a:t>
+              <a:t>Profesora guía: Ana Rosa Moya Beltrán · UTEM, 22 de octubre de 2026</a:t>
             </a:r>
             <a:endParaRPr lang="en-US" sz="1800" dirty="0"/>
           </a:p>

</xml_diff>